<commit_message>
update comprehensive sentiment analysis reports, CSV datasets, and performance visualizations for JMO, Vidio, Halodoc, and Edlink applications.
</commit_message>
<xml_diff>
--- a/edlink-review-analysis/reports/report_edlink.pptx
+++ b/edlink-review-analysis/reports/report_edlink.pptx
@@ -3542,7 +3542,7 @@
               </a:defRPr>
             </a:pPr>
             <a:r>
-              <a:t>• Tanggal Terbit: 23 June 2026</a:t>
+              <a:t>• Tanggal Terbit: 25 June 2026</a:t>
             </a:r>
           </a:p>
         </p:txBody>
@@ -4362,6 +4362,42 @@
           </a:p>
         </p:txBody>
       </p:sp>
+      <p:sp>
+        <p:nvSpPr>
+          <p:cNvPr id="19" name="TextBox 18"/>
+          <p:cNvSpPr txBox="1"/>
+          <p:nvPr/>
+        </p:nvSpPr>
+        <p:spPr>
+          <a:xfrm>
+            <a:off x="731520" y="6126480"/>
+            <a:ext cx="10698480" cy="320040"/>
+          </a:xfrm>
+          <a:prstGeom prst="rect">
+            <a:avLst/>
+          </a:prstGeom>
+          <a:noFill/>
+        </p:spPr>
+        <p:txBody>
+          <a:bodyPr wrap="square" lIns="0" tIns="0" bIns="0" rIns="0">
+            <a:spAutoFit/>
+          </a:bodyPr>
+          <a:lstStyle/>
+          <a:p>
+            <a:pPr>
+              <a:defRPr sz="850">
+                <a:solidFill>
+                  <a:srgbClr val="718096"/>
+                </a:solidFill>
+                <a:latin typeface="Segoe UI"/>
+              </a:defRPr>
+            </a:pPr>
+            <a:r>
+              <a:t>⚠️ Catatan Cakupan Data: Analisis ini hanya mencakup ulasan yang memiliki teks komentar. Ulasan dengan rating tanpa komentar tidak diikutsertakan, sehingga distribusi sentimen mencerminkan pengguna yang aktif memberikan pendapat dan dapat condong ke arah negatif dibanding populasi pengguna keseluruhan.</a:t>
+            </a:r>
+          </a:p>
+        </p:txBody>
+      </p:sp>
     </p:spTree>
   </p:cSld>
   <p:clrMapOvr>
@@ -5137,7 +5173,7 @@
               </a:defRPr>
             </a:pPr>
             <a:r>
-              <a:t>Evaluasi CS: Rata-rata reply rate penanganan keluhan adalah 98.0%. Median delay tanggapan berkisar antara 18.23 - 483.03 jam. Penanganan diarahkan dengan rata-rata pengalihan kontak bantuan/layanan admin sebesar 60.7%.</a:t>
+              <a:t>Evaluasi CS: Rata-rata reply rate penanganan keluhan adalah 97.7%. Median delay tanggapan berkisar antara 0.0 jam. Penanganan diarahkan dengan rata-rata pengalihan kontak bantuan/layanan admin sebesar 60.7%.</a:t>
             </a:r>
           </a:p>
         </p:txBody>

</xml_diff>